<commit_message>
feat: complete multi-language support (EN/PT-BR/ES) for all public pages
</commit_message>
<xml_diff>
--- a/AeroDesk_Pitch_Deck_v3.pptx
+++ b/AeroDesk_Pitch_Deck_v3.pptx
@@ -130,7 +130,7 @@
 <file path=ppt/revisionInfo.xml><?xml version="1.0" encoding="utf-8"?>
 <p1510:revInfo xmlns:a="http://schemas.openxmlformats.org/drawingml/2006/main" xmlns:r="http://schemas.openxmlformats.org/officeDocument/2006/relationships" xmlns:p1510="http://schemas.microsoft.com/office/powerpoint/2015/10/main">
   <p1510:revLst>
-    <p1510:client id="{BBF19347-6823-4A07-B929-A44527AF2C19}" v="23" dt="2026-03-09T13:49:17.041"/>
+    <p1510:client id="{BBF19347-6823-4A07-B929-A44527AF2C19}" v="40" dt="2026-03-17T04:27:35.304"/>
   </p1510:revLst>
 </p1510:revInfo>
 </file>
@@ -140,16 +140,24 @@
   <pc:docChgLst>
     <pc:chgData name="João Pedro Barros de Ávila" userId="848771e9b4f96367" providerId="LiveId" clId="{9BE76701-0D0E-4C8C-A96A-FB4C517B7D18}"/>
     <pc:docChg chg="undo redo custSel addSld delSld modSld addMainMaster modMainMaster">
-      <pc:chgData name="João Pedro Barros de Ávila" userId="848771e9b4f96367" providerId="LiveId" clId="{9BE76701-0D0E-4C8C-A96A-FB4C517B7D18}" dt="2026-03-15T21:51:01.323" v="335" actId="478"/>
+      <pc:chgData name="João Pedro Barros de Ávila" userId="848771e9b4f96367" providerId="LiveId" clId="{9BE76701-0D0E-4C8C-A96A-FB4C517B7D18}" dt="2026-03-17T04:27:56.835" v="411" actId="20577"/>
       <pc:docMkLst>
         <pc:docMk/>
       </pc:docMkLst>
       <pc:sldChg chg="addSp delSp modSp mod modClrScheme chgLayout">
-        <pc:chgData name="João Pedro Barros de Ávila" userId="848771e9b4f96367" providerId="LiveId" clId="{9BE76701-0D0E-4C8C-A96A-FB4C517B7D18}" dt="2026-03-09T13:53:16.234" v="332" actId="1076"/>
+        <pc:chgData name="João Pedro Barros de Ávila" userId="848771e9b4f96367" providerId="LiveId" clId="{9BE76701-0D0E-4C8C-A96A-FB4C517B7D18}" dt="2026-03-17T04:27:08.741" v="386" actId="207"/>
         <pc:sldMkLst>
           <pc:docMk/>
           <pc:sldMk cId="0" sldId="256"/>
         </pc:sldMkLst>
+        <pc:spChg chg="add mod">
+          <ac:chgData name="João Pedro Barros de Ávila" userId="848771e9b4f96367" providerId="LiveId" clId="{9BE76701-0D0E-4C8C-A96A-FB4C517B7D18}" dt="2026-03-17T04:27:08.741" v="386" actId="207"/>
+          <ac:spMkLst>
+            <pc:docMk/>
+            <pc:sldMk cId="0" sldId="256"/>
+            <ac:spMk id="8" creationId="{6F023491-28AC-F1DC-98A0-BEC7440B5F0B}"/>
+          </ac:spMkLst>
+        </pc:spChg>
         <pc:spChg chg="ord">
           <ac:chgData name="João Pedro Barros de Ávila" userId="848771e9b4f96367" providerId="LiveId" clId="{9BE76701-0D0E-4C8C-A96A-FB4C517B7D18}" dt="2026-03-09T13:53:11.711" v="330" actId="167"/>
           <ac:spMkLst>
@@ -166,8 +174,8 @@
             <ac:spMk id="11" creationId="{43233CA9-556D-AA2E-572A-CEA2D3C77F7C}"/>
           </ac:spMkLst>
         </pc:spChg>
-        <pc:spChg chg="add mod ord">
-          <ac:chgData name="João Pedro Barros de Ávila" userId="848771e9b4f96367" providerId="LiveId" clId="{9BE76701-0D0E-4C8C-A96A-FB4C517B7D18}" dt="2026-03-09T13:53:16.234" v="332" actId="1076"/>
+        <pc:spChg chg="add del mod ord">
+          <ac:chgData name="João Pedro Barros de Ávila" userId="848771e9b4f96367" providerId="LiveId" clId="{9BE76701-0D0E-4C8C-A96A-FB4C517B7D18}" dt="2026-03-17T04:25:49.624" v="374" actId="478"/>
           <ac:spMkLst>
             <pc:docMk/>
             <pc:sldMk cId="0" sldId="256"/>
@@ -175,75 +183,155 @@
           </ac:spMkLst>
         </pc:spChg>
       </pc:sldChg>
-      <pc:sldChg chg="delSp mod">
-        <pc:chgData name="João Pedro Barros de Ávila" userId="848771e9b4f96367" providerId="LiveId" clId="{9BE76701-0D0E-4C8C-A96A-FB4C517B7D18}" dt="2026-03-09T11:32:10.515" v="20" actId="21"/>
+      <pc:sldChg chg="addSp delSp modSp mod">
+        <pc:chgData name="João Pedro Barros de Ávila" userId="848771e9b4f96367" providerId="LiveId" clId="{9BE76701-0D0E-4C8C-A96A-FB4C517B7D18}" dt="2026-03-17T04:27:17.487" v="389" actId="1035"/>
         <pc:sldMkLst>
           <pc:docMk/>
           <pc:sldMk cId="0" sldId="257"/>
         </pc:sldMkLst>
+        <pc:spChg chg="add mod">
+          <ac:chgData name="João Pedro Barros de Ávila" userId="848771e9b4f96367" providerId="LiveId" clId="{9BE76701-0D0E-4C8C-A96A-FB4C517B7D18}" dt="2026-03-17T04:27:17.487" v="389" actId="1035"/>
+          <ac:spMkLst>
+            <pc:docMk/>
+            <pc:sldMk cId="0" sldId="257"/>
+            <ac:spMk id="2" creationId="{A7970E34-93C2-DD94-A49E-9C1E9D3388F5}"/>
+          </ac:spMkLst>
+        </pc:spChg>
       </pc:sldChg>
-      <pc:sldChg chg="delSp mod">
-        <pc:chgData name="João Pedro Barros de Ávila" userId="848771e9b4f96367" providerId="LiveId" clId="{9BE76701-0D0E-4C8C-A96A-FB4C517B7D18}" dt="2026-03-09T11:32:55.399" v="33" actId="478"/>
+      <pc:sldChg chg="addSp delSp modSp mod">
+        <pc:chgData name="João Pedro Barros de Ávila" userId="848771e9b4f96367" providerId="LiveId" clId="{9BE76701-0D0E-4C8C-A96A-FB4C517B7D18}" dt="2026-03-17T04:27:19.136" v="390"/>
         <pc:sldMkLst>
           <pc:docMk/>
           <pc:sldMk cId="0" sldId="258"/>
         </pc:sldMkLst>
+        <pc:spChg chg="add mod">
+          <ac:chgData name="João Pedro Barros de Ávila" userId="848771e9b4f96367" providerId="LiveId" clId="{9BE76701-0D0E-4C8C-A96A-FB4C517B7D18}" dt="2026-03-17T04:27:19.136" v="390"/>
+          <ac:spMkLst>
+            <pc:docMk/>
+            <pc:sldMk cId="0" sldId="258"/>
+            <ac:spMk id="2" creationId="{2D7326E8-C626-887A-FB8C-69B0A7A64BC0}"/>
+          </ac:spMkLst>
+        </pc:spChg>
       </pc:sldChg>
-      <pc:sldChg chg="delSp mod">
-        <pc:chgData name="João Pedro Barros de Ávila" userId="848771e9b4f96367" providerId="LiveId" clId="{9BE76701-0D0E-4C8C-A96A-FB4C517B7D18}" dt="2026-03-09T11:32:28.977" v="22" actId="478"/>
+      <pc:sldChg chg="addSp delSp modSp mod">
+        <pc:chgData name="João Pedro Barros de Ávila" userId="848771e9b4f96367" providerId="LiveId" clId="{9BE76701-0D0E-4C8C-A96A-FB4C517B7D18}" dt="2026-03-17T04:27:20.504" v="391"/>
         <pc:sldMkLst>
           <pc:docMk/>
           <pc:sldMk cId="0" sldId="259"/>
         </pc:sldMkLst>
+        <pc:spChg chg="add mod">
+          <ac:chgData name="João Pedro Barros de Ávila" userId="848771e9b4f96367" providerId="LiveId" clId="{9BE76701-0D0E-4C8C-A96A-FB4C517B7D18}" dt="2026-03-17T04:27:20.504" v="391"/>
+          <ac:spMkLst>
+            <pc:docMk/>
+            <pc:sldMk cId="0" sldId="259"/>
+            <ac:spMk id="2" creationId="{C65C98AB-EE64-3A95-EF81-0ECD80BAD209}"/>
+          </ac:spMkLst>
+        </pc:spChg>
       </pc:sldChg>
-      <pc:sldChg chg="delSp mod">
-        <pc:chgData name="João Pedro Barros de Ávila" userId="848771e9b4f96367" providerId="LiveId" clId="{9BE76701-0D0E-4C8C-A96A-FB4C517B7D18}" dt="2026-03-09T11:32:32.334" v="23" actId="478"/>
+      <pc:sldChg chg="addSp delSp modSp mod">
+        <pc:chgData name="João Pedro Barros de Ávila" userId="848771e9b4f96367" providerId="LiveId" clId="{9BE76701-0D0E-4C8C-A96A-FB4C517B7D18}" dt="2026-03-17T04:27:21.693" v="392"/>
         <pc:sldMkLst>
           <pc:docMk/>
           <pc:sldMk cId="0" sldId="260"/>
         </pc:sldMkLst>
+        <pc:spChg chg="add mod">
+          <ac:chgData name="João Pedro Barros de Ávila" userId="848771e9b4f96367" providerId="LiveId" clId="{9BE76701-0D0E-4C8C-A96A-FB4C517B7D18}" dt="2026-03-17T04:27:21.693" v="392"/>
+          <ac:spMkLst>
+            <pc:docMk/>
+            <pc:sldMk cId="0" sldId="260"/>
+            <ac:spMk id="2" creationId="{999EDBB1-F107-0239-B053-6ACCE23E372F}"/>
+          </ac:spMkLst>
+        </pc:spChg>
       </pc:sldChg>
-      <pc:sldChg chg="delSp mod">
-        <pc:chgData name="João Pedro Barros de Ávila" userId="848771e9b4f96367" providerId="LiveId" clId="{9BE76701-0D0E-4C8C-A96A-FB4C517B7D18}" dt="2026-03-09T11:32:33.825" v="24" actId="478"/>
+      <pc:sldChg chg="addSp delSp modSp mod">
+        <pc:chgData name="João Pedro Barros de Ávila" userId="848771e9b4f96367" providerId="LiveId" clId="{9BE76701-0D0E-4C8C-A96A-FB4C517B7D18}" dt="2026-03-17T04:27:22.825" v="393"/>
         <pc:sldMkLst>
           <pc:docMk/>
           <pc:sldMk cId="0" sldId="261"/>
         </pc:sldMkLst>
+        <pc:spChg chg="add mod">
+          <ac:chgData name="João Pedro Barros de Ávila" userId="848771e9b4f96367" providerId="LiveId" clId="{9BE76701-0D0E-4C8C-A96A-FB4C517B7D18}" dt="2026-03-17T04:27:22.825" v="393"/>
+          <ac:spMkLst>
+            <pc:docMk/>
+            <pc:sldMk cId="0" sldId="261"/>
+            <ac:spMk id="2" creationId="{0BF14338-5F12-2CA3-2355-D477F85FC458}"/>
+          </ac:spMkLst>
+        </pc:spChg>
       </pc:sldChg>
-      <pc:sldChg chg="delSp mod">
-        <pc:chgData name="João Pedro Barros de Ávila" userId="848771e9b4f96367" providerId="LiveId" clId="{9BE76701-0D0E-4C8C-A96A-FB4C517B7D18}" dt="2026-03-09T11:32:35.455" v="25" actId="478"/>
+      <pc:sldChg chg="addSp delSp modSp mod">
+        <pc:chgData name="João Pedro Barros de Ávila" userId="848771e9b4f96367" providerId="LiveId" clId="{9BE76701-0D0E-4C8C-A96A-FB4C517B7D18}" dt="2026-03-17T04:27:24.041" v="394"/>
         <pc:sldMkLst>
           <pc:docMk/>
           <pc:sldMk cId="0" sldId="262"/>
         </pc:sldMkLst>
+        <pc:spChg chg="add mod">
+          <ac:chgData name="João Pedro Barros de Ávila" userId="848771e9b4f96367" providerId="LiveId" clId="{9BE76701-0D0E-4C8C-A96A-FB4C517B7D18}" dt="2026-03-17T04:27:24.041" v="394"/>
+          <ac:spMkLst>
+            <pc:docMk/>
+            <pc:sldMk cId="0" sldId="262"/>
+            <ac:spMk id="2" creationId="{A08715A8-C343-A42D-8B37-74BC6E850912}"/>
+          </ac:spMkLst>
+        </pc:spChg>
       </pc:sldChg>
-      <pc:sldChg chg="delSp mod">
-        <pc:chgData name="João Pedro Barros de Ávila" userId="848771e9b4f96367" providerId="LiveId" clId="{9BE76701-0D0E-4C8C-A96A-FB4C517B7D18}" dt="2026-03-09T11:32:36.837" v="26" actId="478"/>
+      <pc:sldChg chg="addSp delSp modSp mod">
+        <pc:chgData name="João Pedro Barros de Ávila" userId="848771e9b4f96367" providerId="LiveId" clId="{9BE76701-0D0E-4C8C-A96A-FB4C517B7D18}" dt="2026-03-17T04:27:25.737" v="395"/>
         <pc:sldMkLst>
           <pc:docMk/>
           <pc:sldMk cId="0" sldId="263"/>
         </pc:sldMkLst>
+        <pc:spChg chg="add mod">
+          <ac:chgData name="João Pedro Barros de Ávila" userId="848771e9b4f96367" providerId="LiveId" clId="{9BE76701-0D0E-4C8C-A96A-FB4C517B7D18}" dt="2026-03-17T04:27:25.737" v="395"/>
+          <ac:spMkLst>
+            <pc:docMk/>
+            <pc:sldMk cId="0" sldId="263"/>
+            <ac:spMk id="2" creationId="{25FBAEB8-0993-6FC0-CCD9-DB72E098DF76}"/>
+          </ac:spMkLst>
+        </pc:spChg>
       </pc:sldChg>
-      <pc:sldChg chg="delSp mod">
-        <pc:chgData name="João Pedro Barros de Ávila" userId="848771e9b4f96367" providerId="LiveId" clId="{9BE76701-0D0E-4C8C-A96A-FB4C517B7D18}" dt="2026-03-09T11:32:38.493" v="27" actId="478"/>
+      <pc:sldChg chg="addSp delSp modSp mod">
+        <pc:chgData name="João Pedro Barros de Ávila" userId="848771e9b4f96367" providerId="LiveId" clId="{9BE76701-0D0E-4C8C-A96A-FB4C517B7D18}" dt="2026-03-17T04:27:27.188" v="396"/>
         <pc:sldMkLst>
           <pc:docMk/>
           <pc:sldMk cId="0" sldId="264"/>
         </pc:sldMkLst>
+        <pc:spChg chg="add mod">
+          <ac:chgData name="João Pedro Barros de Ávila" userId="848771e9b4f96367" providerId="LiveId" clId="{9BE76701-0D0E-4C8C-A96A-FB4C517B7D18}" dt="2026-03-17T04:27:27.188" v="396"/>
+          <ac:spMkLst>
+            <pc:docMk/>
+            <pc:sldMk cId="0" sldId="264"/>
+            <ac:spMk id="2" creationId="{C7946F12-9783-0C2F-B559-1704599784AF}"/>
+          </ac:spMkLst>
+        </pc:spChg>
       </pc:sldChg>
-      <pc:sldChg chg="delSp mod">
-        <pc:chgData name="João Pedro Barros de Ávila" userId="848771e9b4f96367" providerId="LiveId" clId="{9BE76701-0D0E-4C8C-A96A-FB4C517B7D18}" dt="2026-03-09T11:32:40.186" v="28" actId="478"/>
+      <pc:sldChg chg="addSp delSp modSp mod">
+        <pc:chgData name="João Pedro Barros de Ávila" userId="848771e9b4f96367" providerId="LiveId" clId="{9BE76701-0D0E-4C8C-A96A-FB4C517B7D18}" dt="2026-03-17T04:27:28.471" v="397"/>
         <pc:sldMkLst>
           <pc:docMk/>
           <pc:sldMk cId="0" sldId="265"/>
         </pc:sldMkLst>
+        <pc:spChg chg="add mod">
+          <ac:chgData name="João Pedro Barros de Ávila" userId="848771e9b4f96367" providerId="LiveId" clId="{9BE76701-0D0E-4C8C-A96A-FB4C517B7D18}" dt="2026-03-17T04:27:28.471" v="397"/>
+          <ac:spMkLst>
+            <pc:docMk/>
+            <pc:sldMk cId="0" sldId="265"/>
+            <ac:spMk id="2" creationId="{C8EDE475-1547-F733-0823-824CFD497B24}"/>
+          </ac:spMkLst>
+        </pc:spChg>
       </pc:sldChg>
-      <pc:sldChg chg="delSp modSp mod">
-        <pc:chgData name="João Pedro Barros de Ávila" userId="848771e9b4f96367" providerId="LiveId" clId="{9BE76701-0D0E-4C8C-A96A-FB4C517B7D18}" dt="2026-03-09T11:32:41.948" v="29" actId="478"/>
+      <pc:sldChg chg="addSp delSp modSp mod">
+        <pc:chgData name="João Pedro Barros de Ávila" userId="848771e9b4f96367" providerId="LiveId" clId="{9BE76701-0D0E-4C8C-A96A-FB4C517B7D18}" dt="2026-03-17T04:27:29.657" v="398"/>
         <pc:sldMkLst>
           <pc:docMk/>
           <pc:sldMk cId="0" sldId="266"/>
         </pc:sldMkLst>
+        <pc:spChg chg="add mod">
+          <ac:chgData name="João Pedro Barros de Ávila" userId="848771e9b4f96367" providerId="LiveId" clId="{9BE76701-0D0E-4C8C-A96A-FB4C517B7D18}" dt="2026-03-17T04:27:29.657" v="398"/>
+          <ac:spMkLst>
+            <pc:docMk/>
+            <pc:sldMk cId="0" sldId="266"/>
+            <ac:spMk id="2" creationId="{97E7C3CC-44A9-4EC5-8F2D-885F98AF7673}"/>
+          </ac:spMkLst>
+        </pc:spChg>
         <pc:spChg chg="mod">
           <ac:chgData name="João Pedro Barros de Ávila" userId="848771e9b4f96367" providerId="LiveId" clId="{9BE76701-0D0E-4C8C-A96A-FB4C517B7D18}" dt="2026-03-09T11:30:58.868" v="6" actId="20577"/>
           <ac:spMkLst>
@@ -253,29 +341,53 @@
           </ac:spMkLst>
         </pc:spChg>
       </pc:sldChg>
-      <pc:sldChg chg="delSp mod">
-        <pc:chgData name="João Pedro Barros de Ávila" userId="848771e9b4f96367" providerId="LiveId" clId="{9BE76701-0D0E-4C8C-A96A-FB4C517B7D18}" dt="2026-03-09T11:32:43.682" v="30" actId="478"/>
+      <pc:sldChg chg="addSp delSp modSp mod">
+        <pc:chgData name="João Pedro Barros de Ávila" userId="848771e9b4f96367" providerId="LiveId" clId="{9BE76701-0D0E-4C8C-A96A-FB4C517B7D18}" dt="2026-03-17T04:27:31.210" v="399"/>
         <pc:sldMkLst>
           <pc:docMk/>
           <pc:sldMk cId="0" sldId="267"/>
         </pc:sldMkLst>
+        <pc:spChg chg="add mod">
+          <ac:chgData name="João Pedro Barros de Ávila" userId="848771e9b4f96367" providerId="LiveId" clId="{9BE76701-0D0E-4C8C-A96A-FB4C517B7D18}" dt="2026-03-17T04:27:31.210" v="399"/>
+          <ac:spMkLst>
+            <pc:docMk/>
+            <pc:sldMk cId="0" sldId="267"/>
+            <ac:spMk id="2" creationId="{444068FA-50D2-E0F6-DE40-4DEF7E5968F5}"/>
+          </ac:spMkLst>
+        </pc:spChg>
       </pc:sldChg>
-      <pc:sldChg chg="delSp mod">
-        <pc:chgData name="João Pedro Barros de Ávila" userId="848771e9b4f96367" providerId="LiveId" clId="{9BE76701-0D0E-4C8C-A96A-FB4C517B7D18}" dt="2026-03-09T11:32:45.711" v="31" actId="478"/>
+      <pc:sldChg chg="addSp delSp modSp mod">
+        <pc:chgData name="João Pedro Barros de Ávila" userId="848771e9b4f96367" providerId="LiveId" clId="{9BE76701-0D0E-4C8C-A96A-FB4C517B7D18}" dt="2026-03-17T04:27:32.902" v="400"/>
         <pc:sldMkLst>
           <pc:docMk/>
           <pc:sldMk cId="0" sldId="268"/>
         </pc:sldMkLst>
+        <pc:spChg chg="add mod">
+          <ac:chgData name="João Pedro Barros de Ávila" userId="848771e9b4f96367" providerId="LiveId" clId="{9BE76701-0D0E-4C8C-A96A-FB4C517B7D18}" dt="2026-03-17T04:27:32.902" v="400"/>
+          <ac:spMkLst>
+            <pc:docMk/>
+            <pc:sldMk cId="0" sldId="268"/>
+            <ac:spMk id="2" creationId="{8FB2CA29-2227-D3D9-57CF-303F740297EA}"/>
+          </ac:spMkLst>
+        </pc:spChg>
       </pc:sldChg>
-      <pc:sldChg chg="delSp mod">
-        <pc:chgData name="João Pedro Barros de Ávila" userId="848771e9b4f96367" providerId="LiveId" clId="{9BE76701-0D0E-4C8C-A96A-FB4C517B7D18}" dt="2026-03-09T11:32:47.240" v="32" actId="478"/>
+      <pc:sldChg chg="addSp delSp modSp mod">
+        <pc:chgData name="João Pedro Barros de Ávila" userId="848771e9b4f96367" providerId="LiveId" clId="{9BE76701-0D0E-4C8C-A96A-FB4C517B7D18}" dt="2026-03-17T04:27:34.175" v="401"/>
         <pc:sldMkLst>
           <pc:docMk/>
           <pc:sldMk cId="0" sldId="269"/>
         </pc:sldMkLst>
+        <pc:spChg chg="add mod">
+          <ac:chgData name="João Pedro Barros de Ávila" userId="848771e9b4f96367" providerId="LiveId" clId="{9BE76701-0D0E-4C8C-A96A-FB4C517B7D18}" dt="2026-03-17T04:27:34.175" v="401"/>
+          <ac:spMkLst>
+            <pc:docMk/>
+            <pc:sldMk cId="0" sldId="269"/>
+            <ac:spMk id="2" creationId="{C8FF9D88-04A5-5513-B901-84A2794384BE}"/>
+          </ac:spMkLst>
+        </pc:spChg>
       </pc:sldChg>
       <pc:sldChg chg="addSp delSp modSp mod">
-        <pc:chgData name="João Pedro Barros de Ávila" userId="848771e9b4f96367" providerId="LiveId" clId="{9BE76701-0D0E-4C8C-A96A-FB4C517B7D18}" dt="2026-03-15T21:51:01.323" v="335" actId="478"/>
+        <pc:chgData name="João Pedro Barros de Ávila" userId="848771e9b4f96367" providerId="LiveId" clId="{9BE76701-0D0E-4C8C-A96A-FB4C517B7D18}" dt="2026-03-17T04:27:56.835" v="411" actId="20577"/>
         <pc:sldMkLst>
           <pc:docMk/>
           <pc:sldMk cId="0" sldId="270"/>
@@ -296,13 +408,37 @@
             <ac:spMk id="4" creationId="{00000000-0000-0000-0000-000000000000}"/>
           </ac:spMkLst>
         </pc:spChg>
+        <pc:spChg chg="mod">
+          <ac:chgData name="João Pedro Barros de Ávila" userId="848771e9b4f96367" providerId="LiveId" clId="{9BE76701-0D0E-4C8C-A96A-FB4C517B7D18}" dt="2026-03-17T04:27:56.835" v="411" actId="20577"/>
+          <ac:spMkLst>
+            <pc:docMk/>
+            <pc:sldMk cId="0" sldId="270"/>
+            <ac:spMk id="12" creationId="{00000000-0000-0000-0000-000000000000}"/>
+          </ac:spMkLst>
+        </pc:spChg>
+        <pc:spChg chg="add mod">
+          <ac:chgData name="João Pedro Barros de Ávila" userId="848771e9b4f96367" providerId="LiveId" clId="{9BE76701-0D0E-4C8C-A96A-FB4C517B7D18}" dt="2026-03-17T04:27:35.304" v="402"/>
+          <ac:spMkLst>
+            <pc:docMk/>
+            <pc:sldMk cId="0" sldId="270"/>
+            <ac:spMk id="14" creationId="{25C9E3B3-ABA7-711A-A46A-B24F400584E1}"/>
+          </ac:spMkLst>
+        </pc:spChg>
       </pc:sldChg>
-      <pc:sldMasterChg chg="addSp modSp modSldLayout">
-        <pc:chgData name="João Pedro Barros de Ávila" userId="848771e9b4f96367" providerId="LiveId" clId="{9BE76701-0D0E-4C8C-A96A-FB4C517B7D18}" dt="2026-03-09T13:26:11.088" v="65" actId="21"/>
+      <pc:sldMasterChg chg="addSp delSp modSp mod modSldLayout">
+        <pc:chgData name="João Pedro Barros de Ávila" userId="848771e9b4f96367" providerId="LiveId" clId="{9BE76701-0D0E-4C8C-A96A-FB4C517B7D18}" dt="2026-03-17T04:26:33.196" v="376" actId="478"/>
         <pc:sldMasterMkLst>
           <pc:docMk/>
           <pc:sldMasterMk cId="0" sldId="2147483648"/>
         </pc:sldMasterMkLst>
+        <pc:spChg chg="add del mod">
+          <ac:chgData name="João Pedro Barros de Ávila" userId="848771e9b4f96367" providerId="LiveId" clId="{9BE76701-0D0E-4C8C-A96A-FB4C517B7D18}" dt="2026-03-17T04:26:33.196" v="376" actId="478"/>
+          <ac:spMkLst>
+            <pc:docMk/>
+            <pc:sldMasterMk cId="0" sldId="2147483648"/>
+            <ac:spMk id="2" creationId="{F4C64008-6416-678C-C05B-4854C700F9A7}"/>
+          </ac:spMkLst>
+        </pc:spChg>
         <pc:spChg chg="add mod">
           <ac:chgData name="João Pedro Barros de Ávila" userId="848771e9b4f96367" providerId="LiveId" clId="{9BE76701-0D0E-4C8C-A96A-FB4C517B7D18}" dt="2026-03-09T11:32:15.755" v="21"/>
           <ac:spMkLst>
@@ -328,12 +464,20 @@
           </pc:sldLayoutMkLst>
         </pc:sldLayoutChg>
       </pc:sldMasterChg>
-      <pc:sldMasterChg chg="new mod addSldLayout modSldLayout">
-        <pc:chgData name="João Pedro Barros de Ávila" userId="848771e9b4f96367" providerId="LiveId" clId="{9BE76701-0D0E-4C8C-A96A-FB4C517B7D18}" dt="2026-03-09T13:50:55.979" v="322" actId="555"/>
+      <pc:sldMasterChg chg="addSp delSp modSp new mod addSldLayout modSldLayout">
+        <pc:chgData name="João Pedro Barros de Ávila" userId="848771e9b4f96367" providerId="LiveId" clId="{9BE76701-0D0E-4C8C-A96A-FB4C517B7D18}" dt="2026-03-17T04:26:41.099" v="379" actId="478"/>
         <pc:sldMasterMkLst>
           <pc:docMk/>
           <pc:sldMasterMk cId="648317672" sldId="2147483651"/>
         </pc:sldMasterMkLst>
+        <pc:spChg chg="add del mod">
+          <ac:chgData name="João Pedro Barros de Ávila" userId="848771e9b4f96367" providerId="LiveId" clId="{9BE76701-0D0E-4C8C-A96A-FB4C517B7D18}" dt="2026-03-17T04:26:41.099" v="379" actId="478"/>
+          <ac:spMkLst>
+            <pc:docMk/>
+            <pc:sldMasterMk cId="648317672" sldId="2147483651"/>
+            <ac:spMk id="7" creationId="{B54AE03D-D6B1-F08E-35CB-9E352F52DD64}"/>
+          </ac:spMkLst>
+        </pc:spChg>
         <pc:sldLayoutChg chg="new replId">
           <pc:chgData name="João Pedro Barros de Ávila" userId="848771e9b4f96367" providerId="LiveId" clId="{9BE76701-0D0E-4C8C-A96A-FB4C517B7D18}" dt="2026-03-09T13:21:48.870" v="43" actId="6938"/>
           <pc:sldLayoutMkLst>
@@ -3160,7 +3304,7 @@
           <a:p>
             <a:fld id="{1A0E914B-F9C8-4E06-A5D5-7AA34D1FB173}" type="datetimeFigureOut">
               <a:rPr lang="pt-BR" smtClean="0"/>
-              <a:t>15/03/2026</a:t>
+              <a:t>17/03/2026</a:t>
             </a:fld>
             <a:endParaRPr lang="pt-BR"/>
           </a:p>
@@ -3273,7 +3417,7 @@
           <a:p>
             <a:fld id="{1A0E914B-F9C8-4E06-A5D5-7AA34D1FB173}" type="datetimeFigureOut">
               <a:rPr lang="pt-BR" smtClean="0"/>
-              <a:t>15/03/2026</a:t>
+              <a:t>17/03/2026</a:t>
             </a:fld>
             <a:endParaRPr lang="pt-BR"/>
           </a:p>
@@ -3586,7 +3730,7 @@
           <a:p>
             <a:fld id="{1A0E914B-F9C8-4E06-A5D5-7AA34D1FB173}" type="datetimeFigureOut">
               <a:rPr lang="pt-BR" smtClean="0"/>
-              <a:t>15/03/2026</a:t>
+              <a:t>17/03/2026</a:t>
             </a:fld>
             <a:endParaRPr lang="pt-BR"/>
           </a:p>
@@ -3875,7 +4019,7 @@
           <a:p>
             <a:fld id="{1A0E914B-F9C8-4E06-A5D5-7AA34D1FB173}" type="datetimeFigureOut">
               <a:rPr lang="pt-BR" smtClean="0"/>
-              <a:t>15/03/2026</a:t>
+              <a:t>17/03/2026</a:t>
             </a:fld>
             <a:endParaRPr lang="pt-BR"/>
           </a:p>
@@ -4075,7 +4219,7 @@
           <a:p>
             <a:fld id="{1A0E914B-F9C8-4E06-A5D5-7AA34D1FB173}" type="datetimeFigureOut">
               <a:rPr lang="pt-BR" smtClean="0"/>
-              <a:t>15/03/2026</a:t>
+              <a:t>17/03/2026</a:t>
             </a:fld>
             <a:endParaRPr lang="pt-BR"/>
           </a:p>
@@ -4285,7 +4429,7 @@
           <a:p>
             <a:fld id="{1A0E914B-F9C8-4E06-A5D5-7AA34D1FB173}" type="datetimeFigureOut">
               <a:rPr lang="pt-BR" smtClean="0"/>
-              <a:t>15/03/2026</a:t>
+              <a:t>17/03/2026</a:t>
             </a:fld>
             <a:endParaRPr lang="pt-BR"/>
           </a:p>
@@ -4582,7 +4726,7 @@
           <a:p>
             <a:fld id="{1A0E914B-F9C8-4E06-A5D5-7AA34D1FB173}" type="datetimeFigureOut">
               <a:rPr lang="pt-BR" smtClean="0"/>
-              <a:t>15/03/2026</a:t>
+              <a:t>17/03/2026</a:t>
             </a:fld>
             <a:endParaRPr lang="pt-BR"/>
           </a:p>
@@ -5312,7 +5456,7 @@
           <a:p>
             <a:fld id="{1A0E914B-F9C8-4E06-A5D5-7AA34D1FB173}" type="datetimeFigureOut">
               <a:rPr lang="pt-BR" smtClean="0"/>
-              <a:t>15/03/2026</a:t>
+              <a:t>17/03/2026</a:t>
             </a:fld>
             <a:endParaRPr lang="pt-BR"/>
           </a:p>
@@ -5588,7 +5732,7 @@
           <a:p>
             <a:fld id="{1A0E914B-F9C8-4E06-A5D5-7AA34D1FB173}" type="datetimeFigureOut">
               <a:rPr lang="pt-BR" smtClean="0"/>
-              <a:t>15/03/2026</a:t>
+              <a:t>17/03/2026</a:t>
             </a:fld>
             <a:endParaRPr lang="pt-BR"/>
           </a:p>
@@ -5856,7 +6000,7 @@
           <a:p>
             <a:fld id="{1A0E914B-F9C8-4E06-A5D5-7AA34D1FB173}" type="datetimeFigureOut">
               <a:rPr lang="pt-BR" smtClean="0"/>
-              <a:t>15/03/2026</a:t>
+              <a:t>17/03/2026</a:t>
             </a:fld>
             <a:endParaRPr lang="pt-BR"/>
           </a:p>
@@ -6271,7 +6415,7 @@
           <a:p>
             <a:fld id="{1A0E914B-F9C8-4E06-A5D5-7AA34D1FB173}" type="datetimeFigureOut">
               <a:rPr lang="pt-BR" smtClean="0"/>
-              <a:t>15/03/2026</a:t>
+              <a:t>17/03/2026</a:t>
             </a:fld>
             <a:endParaRPr lang="pt-BR"/>
           </a:p>
@@ -6836,7 +6980,7 @@
           <a:p>
             <a:fld id="{1A0E914B-F9C8-4E06-A5D5-7AA34D1FB173}" type="datetimeFigureOut">
               <a:rPr lang="pt-BR" smtClean="0"/>
-              <a:t>15/03/2026</a:t>
+              <a:t>17/03/2026</a:t>
             </a:fld>
             <a:endParaRPr lang="pt-BR"/>
           </a:p>
@@ -7304,31 +7448,6 @@
       </p:sp>
       <p:sp>
         <p:nvSpPr>
-          <p:cNvPr id="12" name="Text Placeholder 11">
-            <a:extLst>
-              <a:ext uri="{FF2B5EF4-FFF2-40B4-BE49-F238E27FC236}">
-                <a16:creationId xmlns:a16="http://schemas.microsoft.com/office/drawing/2014/main" id="{6D92F63B-285F-78A8-ED81-0EE6C4287709}"/>
-              </a:ext>
-            </a:extLst>
-          </p:cNvPr>
-          <p:cNvSpPr>
-            <a:spLocks noGrp="1"/>
-          </p:cNvSpPr>
-          <p:nvPr>
-            <p:ph type="body" sz="quarter" idx="14"/>
-          </p:nvPr>
-        </p:nvSpPr>
-        <p:spPr/>
-        <p:txBody>
-          <a:bodyPr/>
-          <a:lstStyle/>
-          <a:p>
-            <a:endParaRPr lang="pt-BR" dirty="0"/>
-          </a:p>
-        </p:txBody>
-      </p:sp>
-      <p:sp>
-        <p:nvSpPr>
           <p:cNvPr id="11" name="Text Placeholder 10">
             <a:extLst>
               <a:ext uri="{FF2B5EF4-FFF2-40B4-BE49-F238E27FC236}">
@@ -7535,6 +7654,46 @@
           </a:solidFill>
           <a:ln/>
         </p:spPr>
+      </p:sp>
+      <p:sp>
+        <p:nvSpPr>
+          <p:cNvPr id="8" name="TextBox 7">
+            <a:extLst>
+              <a:ext uri="{FF2B5EF4-FFF2-40B4-BE49-F238E27FC236}">
+                <a16:creationId xmlns:a16="http://schemas.microsoft.com/office/drawing/2014/main" id="{6F023491-28AC-F1DC-98A0-BEC7440B5F0B}"/>
+              </a:ext>
+            </a:extLst>
+          </p:cNvPr>
+          <p:cNvSpPr txBox="1"/>
+          <p:nvPr/>
+        </p:nvSpPr>
+        <p:spPr>
+          <a:xfrm rot="19501435">
+            <a:off x="1475379" y="2297288"/>
+            <a:ext cx="5415566" cy="830997"/>
+          </a:xfrm>
+          <a:prstGeom prst="rect">
+            <a:avLst/>
+          </a:prstGeom>
+          <a:noFill/>
+        </p:spPr>
+        <p:txBody>
+          <a:bodyPr wrap="square" rtlCol="0" anchor="ctr">
+            <a:spAutoFit/>
+          </a:bodyPr>
+          <a:lstStyle/>
+          <a:p>
+            <a:pPr algn="ctr"/>
+            <a:r>
+              <a:rPr lang="pt-BR" sz="4800" dirty="0">
+                <a:solidFill>
+                  <a:srgbClr val="D9D9D9"/>
+                </a:solidFill>
+              </a:rPr>
+              <a:t>CONFIDENTIAL</a:t>
+            </a:r>
+          </a:p>
+        </p:txBody>
       </p:sp>
     </p:spTree>
   </p:cSld>
@@ -8496,6 +8655,46 @@
               <a:t>(Online TAM)</a:t>
             </a:r>
             <a:endParaRPr lang="en-US" sz="1000" dirty="0"/>
+          </a:p>
+        </p:txBody>
+      </p:sp>
+      <p:sp>
+        <p:nvSpPr>
+          <p:cNvPr id="2" name="TextBox 1">
+            <a:extLst>
+              <a:ext uri="{FF2B5EF4-FFF2-40B4-BE49-F238E27FC236}">
+                <a16:creationId xmlns:a16="http://schemas.microsoft.com/office/drawing/2014/main" id="{C8EDE475-1547-F733-0823-824CFD497B24}"/>
+              </a:ext>
+            </a:extLst>
+          </p:cNvPr>
+          <p:cNvSpPr txBox="1"/>
+          <p:nvPr/>
+        </p:nvSpPr>
+        <p:spPr>
+          <a:xfrm rot="19501435">
+            <a:off x="1475379" y="2297288"/>
+            <a:ext cx="5415566" cy="830997"/>
+          </a:xfrm>
+          <a:prstGeom prst="rect">
+            <a:avLst/>
+          </a:prstGeom>
+          <a:noFill/>
+        </p:spPr>
+        <p:txBody>
+          <a:bodyPr wrap="square" rtlCol="0" anchor="ctr">
+            <a:spAutoFit/>
+          </a:bodyPr>
+          <a:lstStyle/>
+          <a:p>
+            <a:pPr algn="ctr"/>
+            <a:r>
+              <a:rPr lang="pt-BR" sz="4800" dirty="0">
+                <a:solidFill>
+                  <a:srgbClr val="D9D9D9"/>
+                </a:solidFill>
+              </a:rPr>
+              <a:t>CONFIDENTIAL</a:t>
+            </a:r>
           </a:p>
         </p:txBody>
       </p:sp>
@@ -10755,6 +10954,46 @@
           </a:graphicData>
         </a:graphic>
       </p:graphicFrame>
+      <p:sp>
+        <p:nvSpPr>
+          <p:cNvPr id="2" name="TextBox 1">
+            <a:extLst>
+              <a:ext uri="{FF2B5EF4-FFF2-40B4-BE49-F238E27FC236}">
+                <a16:creationId xmlns:a16="http://schemas.microsoft.com/office/drawing/2014/main" id="{97E7C3CC-44A9-4EC5-8F2D-885F98AF7673}"/>
+              </a:ext>
+            </a:extLst>
+          </p:cNvPr>
+          <p:cNvSpPr txBox="1"/>
+          <p:nvPr/>
+        </p:nvSpPr>
+        <p:spPr>
+          <a:xfrm rot="19501435">
+            <a:off x="1475379" y="2297288"/>
+            <a:ext cx="5415566" cy="830997"/>
+          </a:xfrm>
+          <a:prstGeom prst="rect">
+            <a:avLst/>
+          </a:prstGeom>
+          <a:noFill/>
+        </p:spPr>
+        <p:txBody>
+          <a:bodyPr wrap="square" rtlCol="0" anchor="ctr">
+            <a:spAutoFit/>
+          </a:bodyPr>
+          <a:lstStyle/>
+          <a:p>
+            <a:pPr algn="ctr"/>
+            <a:r>
+              <a:rPr lang="pt-BR" sz="4800" dirty="0">
+                <a:solidFill>
+                  <a:srgbClr val="D9D9D9"/>
+                </a:solidFill>
+              </a:rPr>
+              <a:t>CONFIDENTIAL</a:t>
+            </a:r>
+          </a:p>
+        </p:txBody>
+      </p:sp>
     </p:spTree>
   </p:cSld>
   <p:clrMapOvr>
@@ -11894,6 +12133,46 @@
               <a:t>5%</a:t>
             </a:r>
             <a:endParaRPr lang="en-US" sz="800" dirty="0"/>
+          </a:p>
+        </p:txBody>
+      </p:sp>
+      <p:sp>
+        <p:nvSpPr>
+          <p:cNvPr id="2" name="TextBox 1">
+            <a:extLst>
+              <a:ext uri="{FF2B5EF4-FFF2-40B4-BE49-F238E27FC236}">
+                <a16:creationId xmlns:a16="http://schemas.microsoft.com/office/drawing/2014/main" id="{444068FA-50D2-E0F6-DE40-4DEF7E5968F5}"/>
+              </a:ext>
+            </a:extLst>
+          </p:cNvPr>
+          <p:cNvSpPr txBox="1"/>
+          <p:nvPr/>
+        </p:nvSpPr>
+        <p:spPr>
+          <a:xfrm rot="19501435">
+            <a:off x="1475379" y="2297288"/>
+            <a:ext cx="5415566" cy="830997"/>
+          </a:xfrm>
+          <a:prstGeom prst="rect">
+            <a:avLst/>
+          </a:prstGeom>
+          <a:noFill/>
+        </p:spPr>
+        <p:txBody>
+          <a:bodyPr wrap="square" rtlCol="0" anchor="ctr">
+            <a:spAutoFit/>
+          </a:bodyPr>
+          <a:lstStyle/>
+          <a:p>
+            <a:pPr algn="ctr"/>
+            <a:r>
+              <a:rPr lang="pt-BR" sz="4800" dirty="0">
+                <a:solidFill>
+                  <a:srgbClr val="D9D9D9"/>
+                </a:solidFill>
+              </a:rPr>
+              <a:t>CONFIDENTIAL</a:t>
+            </a:r>
           </a:p>
         </p:txBody>
       </p:sp>
@@ -16228,6 +16507,46 @@
           </a:p>
         </p:txBody>
       </p:sp>
+      <p:sp>
+        <p:nvSpPr>
+          <p:cNvPr id="2" name="TextBox 1">
+            <a:extLst>
+              <a:ext uri="{FF2B5EF4-FFF2-40B4-BE49-F238E27FC236}">
+                <a16:creationId xmlns:a16="http://schemas.microsoft.com/office/drawing/2014/main" id="{8FB2CA29-2227-D3D9-57CF-303F740297EA}"/>
+              </a:ext>
+            </a:extLst>
+          </p:cNvPr>
+          <p:cNvSpPr txBox="1"/>
+          <p:nvPr/>
+        </p:nvSpPr>
+        <p:spPr>
+          <a:xfrm rot="19501435">
+            <a:off x="1475379" y="2297288"/>
+            <a:ext cx="5415566" cy="830997"/>
+          </a:xfrm>
+          <a:prstGeom prst="rect">
+            <a:avLst/>
+          </a:prstGeom>
+          <a:noFill/>
+        </p:spPr>
+        <p:txBody>
+          <a:bodyPr wrap="square" rtlCol="0" anchor="ctr">
+            <a:spAutoFit/>
+          </a:bodyPr>
+          <a:lstStyle/>
+          <a:p>
+            <a:pPr algn="ctr"/>
+            <a:r>
+              <a:rPr lang="pt-BR" sz="4800" dirty="0">
+                <a:solidFill>
+                  <a:srgbClr val="D9D9D9"/>
+                </a:solidFill>
+              </a:rPr>
+              <a:t>CONFIDENTIAL</a:t>
+            </a:r>
+          </a:p>
+        </p:txBody>
+      </p:sp>
     </p:spTree>
   </p:cSld>
   <p:clrMapOvr>
@@ -17052,6 +17371,46 @@
           </a:p>
         </p:txBody>
       </p:sp>
+      <p:sp>
+        <p:nvSpPr>
+          <p:cNvPr id="2" name="TextBox 1">
+            <a:extLst>
+              <a:ext uri="{FF2B5EF4-FFF2-40B4-BE49-F238E27FC236}">
+                <a16:creationId xmlns:a16="http://schemas.microsoft.com/office/drawing/2014/main" id="{C8FF9D88-04A5-5513-B901-84A2794384BE}"/>
+              </a:ext>
+            </a:extLst>
+          </p:cNvPr>
+          <p:cNvSpPr txBox="1"/>
+          <p:nvPr/>
+        </p:nvSpPr>
+        <p:spPr>
+          <a:xfrm rot="19501435">
+            <a:off x="1475379" y="2297288"/>
+            <a:ext cx="5415566" cy="830997"/>
+          </a:xfrm>
+          <a:prstGeom prst="rect">
+            <a:avLst/>
+          </a:prstGeom>
+          <a:noFill/>
+        </p:spPr>
+        <p:txBody>
+          <a:bodyPr wrap="square" rtlCol="0" anchor="ctr">
+            <a:spAutoFit/>
+          </a:bodyPr>
+          <a:lstStyle/>
+          <a:p>
+            <a:pPr algn="ctr"/>
+            <a:r>
+              <a:rPr lang="pt-BR" sz="4800" dirty="0">
+                <a:solidFill>
+                  <a:srgbClr val="D9D9D9"/>
+                </a:solidFill>
+              </a:rPr>
+              <a:t>CONFIDENTIAL</a:t>
+            </a:r>
+          </a:p>
+        </p:txBody>
+      </p:sp>
     </p:spTree>
   </p:cSld>
   <p:clrMapOvr>
@@ -17432,7 +17791,7 @@
                 <a:ea typeface="Calibri" pitchFamily="34" charset="-122"/>
                 <a:cs typeface="Calibri" pitchFamily="34" charset="-120"/>
               </a:rPr>
-              <a:t>aerodesk.com  |  hello@aerodesk.com</a:t>
+              <a:t>Aerodesk-ai.com</a:t>
             </a:r>
             <a:endParaRPr lang="en-US" sz="1100" dirty="0"/>
           </a:p>
@@ -17474,6 +17833,46 @@
               <a:t>CONFIDENTIAL — FOR QUALIFIED INVESTORS ONLY</a:t>
             </a:r>
             <a:endParaRPr lang="en-US" sz="800" dirty="0"/>
+          </a:p>
+        </p:txBody>
+      </p:sp>
+      <p:sp>
+        <p:nvSpPr>
+          <p:cNvPr id="14" name="TextBox 13">
+            <a:extLst>
+              <a:ext uri="{FF2B5EF4-FFF2-40B4-BE49-F238E27FC236}">
+                <a16:creationId xmlns:a16="http://schemas.microsoft.com/office/drawing/2014/main" id="{25C9E3B3-ABA7-711A-A46A-B24F400584E1}"/>
+              </a:ext>
+            </a:extLst>
+          </p:cNvPr>
+          <p:cNvSpPr txBox="1"/>
+          <p:nvPr/>
+        </p:nvSpPr>
+        <p:spPr>
+          <a:xfrm rot="19501435">
+            <a:off x="1475379" y="2297288"/>
+            <a:ext cx="5415566" cy="830997"/>
+          </a:xfrm>
+          <a:prstGeom prst="rect">
+            <a:avLst/>
+          </a:prstGeom>
+          <a:noFill/>
+        </p:spPr>
+        <p:txBody>
+          <a:bodyPr wrap="square" rtlCol="0" anchor="ctr">
+            <a:spAutoFit/>
+          </a:bodyPr>
+          <a:lstStyle/>
+          <a:p>
+            <a:pPr algn="ctr"/>
+            <a:r>
+              <a:rPr lang="pt-BR" sz="4800" dirty="0">
+                <a:solidFill>
+                  <a:srgbClr val="D9D9D9"/>
+                </a:solidFill>
+              </a:rPr>
+              <a:t>CONFIDENTIAL</a:t>
+            </a:r>
           </a:p>
         </p:txBody>
       </p:sp>
@@ -18479,6 +18878,46 @@
           </a:p>
         </p:txBody>
       </p:sp>
+      <p:sp>
+        <p:nvSpPr>
+          <p:cNvPr id="2" name="TextBox 1">
+            <a:extLst>
+              <a:ext uri="{FF2B5EF4-FFF2-40B4-BE49-F238E27FC236}">
+                <a16:creationId xmlns:a16="http://schemas.microsoft.com/office/drawing/2014/main" id="{A7970E34-93C2-DD94-A49E-9C1E9D3388F5}"/>
+              </a:ext>
+            </a:extLst>
+          </p:cNvPr>
+          <p:cNvSpPr txBox="1"/>
+          <p:nvPr/>
+        </p:nvSpPr>
+        <p:spPr>
+          <a:xfrm rot="19501435">
+            <a:off x="1475379" y="2297288"/>
+            <a:ext cx="5415566" cy="830997"/>
+          </a:xfrm>
+          <a:prstGeom prst="rect">
+            <a:avLst/>
+          </a:prstGeom>
+          <a:noFill/>
+        </p:spPr>
+        <p:txBody>
+          <a:bodyPr wrap="square" rtlCol="0" anchor="ctr">
+            <a:spAutoFit/>
+          </a:bodyPr>
+          <a:lstStyle/>
+          <a:p>
+            <a:pPr algn="ctr"/>
+            <a:r>
+              <a:rPr lang="pt-BR" sz="4800" dirty="0">
+                <a:solidFill>
+                  <a:srgbClr val="D9D9D9"/>
+                </a:solidFill>
+              </a:rPr>
+              <a:t>CONFIDENTIAL</a:t>
+            </a:r>
+          </a:p>
+        </p:txBody>
+      </p:sp>
     </p:spTree>
   </p:cSld>
   <p:clrMapOvr>
@@ -19106,6 +19545,46 @@
           </a:p>
         </p:txBody>
       </p:sp>
+      <p:sp>
+        <p:nvSpPr>
+          <p:cNvPr id="2" name="TextBox 1">
+            <a:extLst>
+              <a:ext uri="{FF2B5EF4-FFF2-40B4-BE49-F238E27FC236}">
+                <a16:creationId xmlns:a16="http://schemas.microsoft.com/office/drawing/2014/main" id="{2D7326E8-C626-887A-FB8C-69B0A7A64BC0}"/>
+              </a:ext>
+            </a:extLst>
+          </p:cNvPr>
+          <p:cNvSpPr txBox="1"/>
+          <p:nvPr/>
+        </p:nvSpPr>
+        <p:spPr>
+          <a:xfrm rot="19501435">
+            <a:off x="1475379" y="2297288"/>
+            <a:ext cx="5415566" cy="830997"/>
+          </a:xfrm>
+          <a:prstGeom prst="rect">
+            <a:avLst/>
+          </a:prstGeom>
+          <a:noFill/>
+        </p:spPr>
+        <p:txBody>
+          <a:bodyPr wrap="square" rtlCol="0" anchor="ctr">
+            <a:spAutoFit/>
+          </a:bodyPr>
+          <a:lstStyle/>
+          <a:p>
+            <a:pPr algn="ctr"/>
+            <a:r>
+              <a:rPr lang="pt-BR" sz="4800" dirty="0">
+                <a:solidFill>
+                  <a:srgbClr val="D9D9D9"/>
+                </a:solidFill>
+              </a:rPr>
+              <a:t>CONFIDENTIAL</a:t>
+            </a:r>
+          </a:p>
+        </p:txBody>
+      </p:sp>
     </p:spTree>
   </p:cSld>
   <p:clrMapOvr>
@@ -19995,6 +20474,46 @@
           </a:p>
         </p:txBody>
       </p:sp>
+      <p:sp>
+        <p:nvSpPr>
+          <p:cNvPr id="2" name="TextBox 1">
+            <a:extLst>
+              <a:ext uri="{FF2B5EF4-FFF2-40B4-BE49-F238E27FC236}">
+                <a16:creationId xmlns:a16="http://schemas.microsoft.com/office/drawing/2014/main" id="{C65C98AB-EE64-3A95-EF81-0ECD80BAD209}"/>
+              </a:ext>
+            </a:extLst>
+          </p:cNvPr>
+          <p:cNvSpPr txBox="1"/>
+          <p:nvPr/>
+        </p:nvSpPr>
+        <p:spPr>
+          <a:xfrm rot="19501435">
+            <a:off x="1475379" y="2297288"/>
+            <a:ext cx="5415566" cy="830997"/>
+          </a:xfrm>
+          <a:prstGeom prst="rect">
+            <a:avLst/>
+          </a:prstGeom>
+          <a:noFill/>
+        </p:spPr>
+        <p:txBody>
+          <a:bodyPr wrap="square" rtlCol="0" anchor="ctr">
+            <a:spAutoFit/>
+          </a:bodyPr>
+          <a:lstStyle/>
+          <a:p>
+            <a:pPr algn="ctr"/>
+            <a:r>
+              <a:rPr lang="pt-BR" sz="4800" dirty="0">
+                <a:solidFill>
+                  <a:srgbClr val="D9D9D9"/>
+                </a:solidFill>
+              </a:rPr>
+              <a:t>CONFIDENTIAL</a:t>
+            </a:r>
+          </a:p>
+        </p:txBody>
+      </p:sp>
     </p:spTree>
   </p:cSld>
   <p:clrMapOvr>
@@ -20753,6 +21272,46 @@
           </a:p>
         </p:txBody>
       </p:sp>
+      <p:sp>
+        <p:nvSpPr>
+          <p:cNvPr id="2" name="TextBox 1">
+            <a:extLst>
+              <a:ext uri="{FF2B5EF4-FFF2-40B4-BE49-F238E27FC236}">
+                <a16:creationId xmlns:a16="http://schemas.microsoft.com/office/drawing/2014/main" id="{999EDBB1-F107-0239-B053-6ACCE23E372F}"/>
+              </a:ext>
+            </a:extLst>
+          </p:cNvPr>
+          <p:cNvSpPr txBox="1"/>
+          <p:nvPr/>
+        </p:nvSpPr>
+        <p:spPr>
+          <a:xfrm rot="19501435">
+            <a:off x="1475379" y="2297288"/>
+            <a:ext cx="5415566" cy="830997"/>
+          </a:xfrm>
+          <a:prstGeom prst="rect">
+            <a:avLst/>
+          </a:prstGeom>
+          <a:noFill/>
+        </p:spPr>
+        <p:txBody>
+          <a:bodyPr wrap="square" rtlCol="0" anchor="ctr">
+            <a:spAutoFit/>
+          </a:bodyPr>
+          <a:lstStyle/>
+          <a:p>
+            <a:pPr algn="ctr"/>
+            <a:r>
+              <a:rPr lang="pt-BR" sz="4800" dirty="0">
+                <a:solidFill>
+                  <a:srgbClr val="D9D9D9"/>
+                </a:solidFill>
+              </a:rPr>
+              <a:t>CONFIDENTIAL</a:t>
+            </a:r>
+          </a:p>
+        </p:txBody>
+      </p:sp>
     </p:spTree>
   </p:cSld>
   <p:clrMapOvr>
@@ -21893,6 +22452,46 @@
               <a:t>7+ years leading 30+ M&amp;A transactions, deep Brazil aviation network, investment banking pedigree, and technical marketplace-building capability.</a:t>
             </a:r>
             <a:endParaRPr lang="en-US" sz="850" dirty="0"/>
+          </a:p>
+        </p:txBody>
+      </p:sp>
+      <p:sp>
+        <p:nvSpPr>
+          <p:cNvPr id="2" name="TextBox 1">
+            <a:extLst>
+              <a:ext uri="{FF2B5EF4-FFF2-40B4-BE49-F238E27FC236}">
+                <a16:creationId xmlns:a16="http://schemas.microsoft.com/office/drawing/2014/main" id="{0BF14338-5F12-2CA3-2355-D477F85FC458}"/>
+              </a:ext>
+            </a:extLst>
+          </p:cNvPr>
+          <p:cNvSpPr txBox="1"/>
+          <p:nvPr/>
+        </p:nvSpPr>
+        <p:spPr>
+          <a:xfrm rot="19501435">
+            <a:off x="1475379" y="2297288"/>
+            <a:ext cx="5415566" cy="830997"/>
+          </a:xfrm>
+          <a:prstGeom prst="rect">
+            <a:avLst/>
+          </a:prstGeom>
+          <a:noFill/>
+        </p:spPr>
+        <p:txBody>
+          <a:bodyPr wrap="square" rtlCol="0" anchor="ctr">
+            <a:spAutoFit/>
+          </a:bodyPr>
+          <a:lstStyle/>
+          <a:p>
+            <a:pPr algn="ctr"/>
+            <a:r>
+              <a:rPr lang="pt-BR" sz="4800" dirty="0">
+                <a:solidFill>
+                  <a:srgbClr val="D9D9D9"/>
+                </a:solidFill>
+              </a:rPr>
+              <a:t>CONFIDENTIAL</a:t>
+            </a:r>
           </a:p>
         </p:txBody>
       </p:sp>
@@ -24234,6 +24833,46 @@
           </a:p>
         </p:txBody>
       </p:sp>
+      <p:sp>
+        <p:nvSpPr>
+          <p:cNvPr id="2" name="TextBox 1">
+            <a:extLst>
+              <a:ext uri="{FF2B5EF4-FFF2-40B4-BE49-F238E27FC236}">
+                <a16:creationId xmlns:a16="http://schemas.microsoft.com/office/drawing/2014/main" id="{A08715A8-C343-A42D-8B37-74BC6E850912}"/>
+              </a:ext>
+            </a:extLst>
+          </p:cNvPr>
+          <p:cNvSpPr txBox="1"/>
+          <p:nvPr/>
+        </p:nvSpPr>
+        <p:spPr>
+          <a:xfrm rot="19501435">
+            <a:off x="1475379" y="2297288"/>
+            <a:ext cx="5415566" cy="830997"/>
+          </a:xfrm>
+          <a:prstGeom prst="rect">
+            <a:avLst/>
+          </a:prstGeom>
+          <a:noFill/>
+        </p:spPr>
+        <p:txBody>
+          <a:bodyPr wrap="square" rtlCol="0" anchor="ctr">
+            <a:spAutoFit/>
+          </a:bodyPr>
+          <a:lstStyle/>
+          <a:p>
+            <a:pPr algn="ctr"/>
+            <a:r>
+              <a:rPr lang="pt-BR" sz="4800" dirty="0">
+                <a:solidFill>
+                  <a:srgbClr val="D9D9D9"/>
+                </a:solidFill>
+              </a:rPr>
+              <a:t>CONFIDENTIAL</a:t>
+            </a:r>
+          </a:p>
+        </p:txBody>
+      </p:sp>
     </p:spTree>
   </p:cSld>
   <p:clrMapOvr>
@@ -25626,6 +26265,46 @@
           </a:p>
         </p:txBody>
       </p:sp>
+      <p:sp>
+        <p:nvSpPr>
+          <p:cNvPr id="2" name="TextBox 1">
+            <a:extLst>
+              <a:ext uri="{FF2B5EF4-FFF2-40B4-BE49-F238E27FC236}">
+                <a16:creationId xmlns:a16="http://schemas.microsoft.com/office/drawing/2014/main" id="{25FBAEB8-0993-6FC0-CCD9-DB72E098DF76}"/>
+              </a:ext>
+            </a:extLst>
+          </p:cNvPr>
+          <p:cNvSpPr txBox="1"/>
+          <p:nvPr/>
+        </p:nvSpPr>
+        <p:spPr>
+          <a:xfrm rot="19501435">
+            <a:off x="1475379" y="2297288"/>
+            <a:ext cx="5415566" cy="830997"/>
+          </a:xfrm>
+          <a:prstGeom prst="rect">
+            <a:avLst/>
+          </a:prstGeom>
+          <a:noFill/>
+        </p:spPr>
+        <p:txBody>
+          <a:bodyPr wrap="square" rtlCol="0" anchor="ctr">
+            <a:spAutoFit/>
+          </a:bodyPr>
+          <a:lstStyle/>
+          <a:p>
+            <a:pPr algn="ctr"/>
+            <a:r>
+              <a:rPr lang="pt-BR" sz="4800" dirty="0">
+                <a:solidFill>
+                  <a:srgbClr val="D9D9D9"/>
+                </a:solidFill>
+              </a:rPr>
+              <a:t>CONFIDENTIAL</a:t>
+            </a:r>
+          </a:p>
+        </p:txBody>
+      </p:sp>
     </p:spTree>
   </p:cSld>
   <p:clrMapOvr>
@@ -26776,6 +27455,46 @@
               <a:t>Google Ads (PT)</a:t>
             </a:r>
             <a:endParaRPr lang="en-US" sz="850" dirty="0"/>
+          </a:p>
+        </p:txBody>
+      </p:sp>
+      <p:sp>
+        <p:nvSpPr>
+          <p:cNvPr id="2" name="TextBox 1">
+            <a:extLst>
+              <a:ext uri="{FF2B5EF4-FFF2-40B4-BE49-F238E27FC236}">
+                <a16:creationId xmlns:a16="http://schemas.microsoft.com/office/drawing/2014/main" id="{C7946F12-9783-0C2F-B559-1704599784AF}"/>
+              </a:ext>
+            </a:extLst>
+          </p:cNvPr>
+          <p:cNvSpPr txBox="1"/>
+          <p:nvPr/>
+        </p:nvSpPr>
+        <p:spPr>
+          <a:xfrm rot="19501435">
+            <a:off x="1475379" y="2297288"/>
+            <a:ext cx="5415566" cy="830997"/>
+          </a:xfrm>
+          <a:prstGeom prst="rect">
+            <a:avLst/>
+          </a:prstGeom>
+          <a:noFill/>
+        </p:spPr>
+        <p:txBody>
+          <a:bodyPr wrap="square" rtlCol="0" anchor="ctr">
+            <a:spAutoFit/>
+          </a:bodyPr>
+          <a:lstStyle/>
+          <a:p>
+            <a:pPr algn="ctr"/>
+            <a:r>
+              <a:rPr lang="pt-BR" sz="4800" dirty="0">
+                <a:solidFill>
+                  <a:srgbClr val="D9D9D9"/>
+                </a:solidFill>
+              </a:rPr>
+              <a:t>CONFIDENTIAL</a:t>
+            </a:r>
           </a:p>
         </p:txBody>
       </p:sp>

</xml_diff>